<commit_message>
course 10 slides recompiled
</commit_message>
<xml_diff>
--- a/Course10/slides.pptx
+++ b/Course10/slides.pptx
@@ -5,7 +5,7 @@
     <p:sldMasterId id="2147483648" r:id="rId1"/>
   </p:sldMasterIdLst>
   <p:notesMasterIdLst>
-    <p:notesMasterId r:id="rId37"/>
+    <p:notesMasterId r:id="rId39"/>
   </p:notesMasterIdLst>
   <p:sldIdLst>
     <p:sldId id="256" r:id="rId2"/>
@@ -43,6 +43,8 @@
     <p:sldId id="288" r:id="rId34"/>
     <p:sldId id="289" r:id="rId35"/>
     <p:sldId id="290" r:id="rId36"/>
+    <p:sldId id="291" r:id="rId37"/>
+    <p:sldId id="292" r:id="rId38"/>
   </p:sldIdLst>
   <p:sldSz cx="9144000" cy="5143500" type="screen16x9"/>
   <p:notesSz cx="6858000" cy="9144000"/>
@@ -1214,7 +1216,7 @@
             </a:pPr>
             <a:r>
               <a:rPr/>
-              <a:t>One gate per question. On “patients”: write “plural subject” (input gate open). During “who were admitted on Monday after the accident”: keep it (forget gate ≈ 1), but there is no need to show it. On the verb: show it (output gate open), the network predicts “were” and not “was”. After the verb: it can be erased (forget gate ≈ 0).</a:t>
+              <a:t>Top: the memory line. It is multiplied by the forget gate f (erase), then the input gate i times the candidate c~ is added (write). Bottom: the four boxes all read the same inputs, h_{t-1} and x_t: three sigmoids (gates) and one tanh (candidate, the same formula as a simple RNN). Right: the new state h_t is a tanh of the memory, filtered by the output gate o. Two states go to the next step: c_t and h_t.</a:t>
             </a:r>
           </a:p>
         </p:txBody>
@@ -1296,7 +1298,7 @@
             </a:pPr>
             <a:r>
               <a:rPr/>
-              <a:t>Top: the memory line. It is multiplied by the forget gate f (erase), then the input gate i times the candidate c~ is added (write). Bottom: the four boxes all read the same inputs, h_{t-1} and x_t: three sigmoids (gates) and one tanh (candidate, the same formula as a simple RNN). Right: the new state h_t is a tanh of the memory, filtered by the output gate o. Two states go to the next step: c_t and h_t.</a:t>
+              <a:t>Each gate is a small layer of its own, with the same form as a simple RNN: four weight blocks instead of one, so four times the parameters for the same hidden size. The forget gate was not in the 1997 paper; it was added by Gers, Schmidhuber and Cummins (2000), and it is the one that makes LSTMs work in practice.</a:t>
             </a:r>
           </a:p>
         </p:txBody>
@@ -1378,7 +1380,7 @@
             </a:pPr>
             <a:r>
               <a:rPr/>
-              <a:t>Each gate is a small layer of its own, with the same form as a simple RNN: four weight blocks instead of one, so four times the parameters for the same hidden size. The forget gate was not in the 1997 paper; it was added by Gers, Schmidhuber and Cummins (2000), and it is the one that makes LSTMs work in practice.</a:t>
+              <a:t>Compare with the simple RNN, where each step back multiplies the gradient by W_hh and by tanh’ (both usually small). Along the memory line, each step back only multiplies by f_t, and the network can learn f_t ≈ 1 for whatever must be kept: the gradient survives hundreds of steps (ignoring the indirect paths through the gates). It is the same trick as the skip connections of ResNets: an additive path. Exploding gradients are still possible: keep gradient clipping.</a:t>
             </a:r>
           </a:p>
         </p:txBody>
@@ -1542,7 +1544,7 @@
             </a:pPr>
             <a:r>
               <a:rPr/>
-              <a:t>Compare with the simple RNN, where each step back multiplies the gradient by W_hh and by tanh’ (both usually small). Along the memory line, each step back only multiplies by f_t, and the network can learn f_t ≈ 1 for whatever must be kept: the gradient survives hundreds of steps (ignoring the indirect paths through the gates). It is the same trick as the skip connections of ResNets: an additive path. Exploding gradients are still possible: keep gradient clipping.</a:t>
+              <a:t>Cho et al. (2014) kept the idea — an additive, gated path through time — and made it simpler. One state instead of two. One update gate z for erasing and writing at once: what is written replaces exactly what is erased (keep 1 − z of the old state, write z of the new). No output gate. And a reset gate r, which lets the candidate ignore the past (r ≈ 0) when something new starts. Chung et al. (2014) found no clear winner between the two.</a:t>
             </a:r>
           </a:p>
         </p:txBody>
@@ -1624,7 +1626,7 @@
             </a:pPr>
             <a:r>
               <a:rPr/>
-              <a:t>Cho et al. (2014) kept the idea — an additive, gated path through time — and made it simpler. One state instead of two. One update gate z for erasing and writing at once: what is written replaces exactly what is erased (keep 1 − z of the old state, write z of the new). No output gate. And a reset gate r, which lets the candidate ignore the past (r ≈ 0) when something new starts. Chung et al. (2014) found no clear winner between the two.</a:t>
+              <a:t>Same colours as the LSTM. The top line is now the state itself: it plays the role of the LSTM memory. The update gate z feeds two branches: 1 − z multiplies the old state (keep), z multiplies the candidate (write) — erasing and writing are tied. The reset gate r filters h_{t-1} before the candidate sees it: r ≈ 0 means “start afresh”. No output gate, no tanh on the way out: the state is shown as is.</a:t>
             </a:r>
           </a:p>
         </p:txBody>
@@ -1788,7 +1790,7 @@
             </a:pPr>
             <a:r>
               <a:rPr/>
-              <a:t>Both are drop-in replacements for nn.RNN. Ask before the next slide: what are the shapes of h and c? Of weight_hh_l0?</a:t>
+              <a:t>Same frame, same colours. Both keep a green line that is only multiplied by a gate and added to — that is what lets the gradient through. The LSTM has a separate memory c and shows part of it as h (output gate); the GRU merges them. The LSTM erases (f) and writes (i) independently; the GRU ties them (1 − z and z). The GRU’s reset gate has no LSTM counterpart.</a:t>
             </a:r>
           </a:p>
         </p:txBody>
@@ -1869,14 +1871,8 @@
               <a:buNone/>
             </a:pPr>
             <a:r>
-              <a:rPr>
-                <a:latin typeface="Courier"/>
-              </a:rPr>
-              <a:t>out</a:t>
-            </a:r>
-            <a:r>
               <a:rPr/>
-              <a:t> is [64, 32, 256] for both: the state h at every step. The LSTM also returns its memory c. PyTorch stacks the weight blocks of the gates in one matrix: 4 × 256 rows for the LSTM (i, f, c~, o), 3 × 256 for the GRU (r, z, candidate). With 100 inputs and 256 hidden units: 366,592 parameters for the LSTM, 274,944 for the GRU, 91,648 for a simple RNN.</a:t>
+              <a:t>Row by row. Gates: three for the LSTM, two for the GRU. Candidate: the same tanh layer, except that the GRU’s sees r ⊙ h_{t-1}. Memory update: f and i in the LSTM, 1 − z and z in the GRU. State: the LSTM filters its memory through o and a tanh; the GRU has nothing to do. Four weight blocks against three: 25% fewer parameters.</a:t>
             </a:r>
           </a:p>
         </p:txBody>
@@ -1958,7 +1954,7 @@
             </a:pPr>
             <a:r>
               <a:rPr/>
-              <a:t>The target is the input shifted by one word. At every position the network outputs a probability for every word of the vocabulary, and we take the cross-entropy with the word that actually comes next. One sequence of 32 words gives 32 training examples, and no labels are needed: the text is its own supervision.</a:t>
+              <a:t>Both are drop-in replacements for nn.RNN. Ask before the next slide: what are the shapes of h and c? Of weight_hh_l0?</a:t>
             </a:r>
           </a:p>
         </p:txBody>
@@ -1980,7 +1976,7 @@
           <a:p>
             <a:fld id="{18BDFEC3-8487-43E8-A154-7C12CBC1FFF2}" type="slidenum">
               <a:rPr lang="en-US"/>
-              <a:t>28</a:t>
+              <a:t>27</a:t>
             </a:fld>
             <a:endParaRPr lang="en-US"/>
           </a:p>
@@ -2040,7 +2036,7 @@
             </a:pPr>
             <a:r>
               <a:rPr/>
-              <a:t>The cross-entropy is in nats, which is hard to read; its exponential is on an intuitive scale. A perplexity of 150: the model is as unsure as if it picked uniformly among 150 words. Accuracy (is the top word the right one?) is also reported, but it ignores how much probability the right word got. Caveat: a smaller vocabulary (more words mapped to UNK) makes the task easier, so perplexities are only comparable on the same vocabulary and the same test text.</a:t>
+              <a:t>The target is the input shifted by one word. At every position the network outputs a probability for every word of the vocabulary, and we take the cross-entropy with the word that actually comes next. One sequence of 32 words gives 32 training examples, and no labels are needed: the text is its own supervision.</a:t>
             </a:r>
           </a:p>
         </p:txBody>
@@ -2122,7 +2118,7 @@
             </a:pPr>
             <a:r>
               <a:rPr/>
-              <a:t>10.4M parameters against 2.3M: the first and the last layers are huge. Going through a vector of size 100 on both sides divides the model by 4.5. And the input is 99.99% zeros — 82 MB for one batch, where the word indices take 16 kB.</a:t>
+              <a:t>The cross-entropy is in nats, which is hard to read; its exponential is on an intuitive scale. A perplexity of 150: the model is as unsure as if it picked uniformly among 150 words. Accuracy (is the top word the right one?) is also reported, but it ignores how much probability the right word got. Caveat: a smaller vocabulary (more words mapped to UNK) makes the task easier, so perplexities are only comparable on the same vocabulary and the same test text.</a:t>
             </a:r>
           </a:p>
         </p:txBody>
@@ -2144,7 +2140,7 @@
           <a:p>
             <a:fld id="{18BDFEC3-8487-43E8-A154-7C12CBC1FFF2}" type="slidenum">
               <a:rPr lang="en-US"/>
-              <a:t>31</a:t>
+              <a:t>30</a:t>
             </a:fld>
             <a:endParaRPr lang="en-US"/>
           </a:p>
@@ -2204,7 +2200,7 @@
             </a:pPr>
             <a:r>
               <a:rPr/>
-              <a:t>Multiplying a one-hot vector by a matrix just reads one column. So a linear layer on one-hot inputs is a lookup table.</a:t>
+              <a:t>For one word, perplexity is 1 / p(correct word). Uniform over 8 words: 8, the model hesitates between 8. Between 2 words: 2. Sure and right: 1, the best possible. Sure and wrong: 100 — a confident mistake costs far more than hesitation, which is why the cross-entropy (and so the perplexity) punishes over-confidence. Over a text, it is the geometric mean of 1 / p(correct word) over all positions, i.e. exp(cross-entropy).</a:t>
             </a:r>
           </a:p>
         </p:txBody>
@@ -2226,7 +2222,7 @@
           <a:p>
             <a:fld id="{18BDFEC3-8487-43E8-A154-7C12CBC1FFF2}" type="slidenum">
               <a:rPr lang="en-US"/>
-              <a:t>32</a:t>
+              <a:t>31</a:t>
             </a:fld>
             <a:endParaRPr lang="en-US"/>
           </a:p>
@@ -2286,7 +2282,7 @@
             </a:pPr>
             <a:r>
               <a:rPr/>
-              <a:t>Reminder. CBOW predicts a word from its context; the encoder’s column j is the embedding of word j. It also learns a decoder: from a vector of size 100 to a score per word — exactly the two pieces our language model needs. word2vec (Mikolov et al., 2013) is the official version of the same idea, with tricks that make it much better and much faster: negative sampling (push the right word up and 5 random words down, instead of a softmax over 10 001 words), and subsampling of very frequent words like “the”. We use gensim’s implementation.</a:t>
+              <a:t>10.4M parameters against 2.3M: the first and the last layers are huge. Going through a vector of size 100 on both sides divides the model by 4.5. And the input is 99.99% zeros — 82 MB for one batch, where the word indices take 16 kB.</a:t>
             </a:r>
           </a:p>
         </p:txBody>
@@ -2308,7 +2304,7 @@
           <a:p>
             <a:fld id="{18BDFEC3-8487-43E8-A154-7C12CBC1FFF2}" type="slidenum">
               <a:rPr lang="en-US"/>
-              <a:t>33</a:t>
+              <a:t>32</a:t>
             </a:fld>
             <a:endParaRPr lang="en-US"/>
           </a:p>
@@ -2450,21 +2446,7 @@
             </a:pPr>
             <a:r>
               <a:rPr/>
-              <a:t>Three experiments, one architecture. Frozen: embedding and decoder come from CBOW or from word2vec and are not trained; only the GRU and the small linear layer are. End to end: same layers, random initialisation, everything trained on the next-word task.</a:t>
-            </a:r>
-          </a:p>
-          <a:p>
-            <a:pPr lvl="0" indent="0" marL="0">
-              <a:buNone/>
-            </a:pPr>
-          </a:p>
-          <a:p>
-            <a:pPr lvl="0" indent="0" marL="0">
-              <a:buNone/>
-            </a:pPr>
-            <a:r>
-              <a:rPr/>
-              <a:t>One detail for word2vec: its decoder has no bias. With negative sampling, the score approximates log p(w | context) − log p(w), up to a constant, so we add the fixed bias log p(w), the frequency of each word. That turns the scores into log-probabilities without training anything.</a:t>
+              <a:t>Multiplying a one-hot vector by a matrix just reads one column. So a linear layer on one-hot inputs is a lookup table.</a:t>
             </a:r>
           </a:p>
         </p:txBody>
@@ -2487,6 +2469,184 @@
             <a:fld id="{18BDFEC3-8487-43E8-A154-7C12CBC1FFF2}" type="slidenum">
               <a:rPr lang="en-US"/>
               <a:t>34</a:t>
+            </a:fld>
+            <a:endParaRPr lang="en-US"/>
+          </a:p>
+        </p:txBody>
+      </p:sp>
+    </p:spTree>
+  </p:cSld>
+</p:notes>
+</file>
+
+<file path=ppt/notesSlides/notesSlide31.xml><?xml version="1.0" encoding="utf-8"?>
+<p:notes xmlns:a="http://schemas.openxmlformats.org/drawingml/2006/main" xmlns:r="http://schemas.openxmlformats.org/officeDocument/2006/relationships" xmlns:p="http://schemas.openxmlformats.org/presentationml/2006/main">
+  <p:cSld>
+    <p:spTree>
+      <p:nvGrpSpPr>
+        <p:cNvPr id="1" name=""/>
+        <p:cNvGrpSpPr/>
+        <p:nvPr/>
+      </p:nvGrpSpPr>
+      <p:grpSpPr>
+        <a:xfrm>
+          <a:off x="0" y="0"/>
+          <a:ext cx="0" cy="0"/>
+          <a:chOff x="0" y="0"/>
+          <a:chExt cx="0" cy="0"/>
+        </a:xfrm>
+      </p:grpSpPr>
+      <p:sp>
+        <p:nvSpPr>
+          <p:cNvPr id="2" name="Slide Image Placeholder 1"/>
+          <p:cNvSpPr>
+            <a:spLocks noGrp="1" noRot="1" noChangeAspect="1"/>
+          </p:cNvSpPr>
+          <p:nvPr>
+            <p:ph type="sldImg"/>
+          </p:nvPr>
+        </p:nvSpPr>
+        <p:spPr/>
+      </p:sp>
+      <p:sp>
+        <p:nvSpPr>
+          <p:cNvPr id="3" name="Notes Placeholder 2"/>
+          <p:cNvSpPr>
+            <a:spLocks noGrp="1"/>
+          </p:cNvSpPr>
+          <p:nvPr>
+            <p:ph type="body" idx="1"/>
+          </p:nvPr>
+        </p:nvSpPr>
+        <p:spPr/>
+        <p:txBody>
+          <a:bodyPr/>
+          <a:lstStyle/>
+          <a:p>
+            <a:pPr lvl="0" indent="0" marL="0">
+              <a:buNone/>
+            </a:pPr>
+            <a:r>
+              <a:rPr/>
+              <a:t>Reminder. CBOW predicts a word from its context; the encoder’s column j is the embedding of word j. It also learns a decoder: from a vector of size 100 to a score per word — exactly the two pieces our language model needs. word2vec (Mikolov et al., 2013) is the official version of the same idea, with tricks that make it much better and much faster: negative sampling (push the right word up and 5 random words down, instead of a softmax over 10 001 words), and subsampling of very frequent words like “the”. We use gensim’s implementation.</a:t>
+            </a:r>
+          </a:p>
+        </p:txBody>
+      </p:sp>
+      <p:sp>
+        <p:nvSpPr>
+          <p:cNvPr id="4" name="Slide Number Placeholder 3"/>
+          <p:cNvSpPr>
+            <a:spLocks noGrp="1"/>
+          </p:cNvSpPr>
+          <p:nvPr>
+            <p:ph type="sldNum" sz="quarter" idx="10"/>
+          </p:nvPr>
+        </p:nvSpPr>
+        <p:spPr/>
+        <p:txBody>
+          <a:bodyPr/>
+          <a:lstStyle/>
+          <a:p>
+            <a:fld id="{18BDFEC3-8487-43E8-A154-7C12CBC1FFF2}" type="slidenum">
+              <a:rPr lang="en-US"/>
+              <a:t>35</a:t>
+            </a:fld>
+            <a:endParaRPr lang="en-US"/>
+          </a:p>
+        </p:txBody>
+      </p:sp>
+    </p:spTree>
+  </p:cSld>
+</p:notes>
+</file>
+
+<file path=ppt/notesSlides/notesSlide32.xml><?xml version="1.0" encoding="utf-8"?>
+<p:notes xmlns:a="http://schemas.openxmlformats.org/drawingml/2006/main" xmlns:r="http://schemas.openxmlformats.org/officeDocument/2006/relationships" xmlns:p="http://schemas.openxmlformats.org/presentationml/2006/main">
+  <p:cSld>
+    <p:spTree>
+      <p:nvGrpSpPr>
+        <p:cNvPr id="1" name=""/>
+        <p:cNvGrpSpPr/>
+        <p:nvPr/>
+      </p:nvGrpSpPr>
+      <p:grpSpPr>
+        <a:xfrm>
+          <a:off x="0" y="0"/>
+          <a:ext cx="0" cy="0"/>
+          <a:chOff x="0" y="0"/>
+          <a:chExt cx="0" cy="0"/>
+        </a:xfrm>
+      </p:grpSpPr>
+      <p:sp>
+        <p:nvSpPr>
+          <p:cNvPr id="2" name="Slide Image Placeholder 1"/>
+          <p:cNvSpPr>
+            <a:spLocks noGrp="1" noRot="1" noChangeAspect="1"/>
+          </p:cNvSpPr>
+          <p:nvPr>
+            <p:ph type="sldImg"/>
+          </p:nvPr>
+        </p:nvSpPr>
+        <p:spPr/>
+      </p:sp>
+      <p:sp>
+        <p:nvSpPr>
+          <p:cNvPr id="3" name="Notes Placeholder 2"/>
+          <p:cNvSpPr>
+            <a:spLocks noGrp="1"/>
+          </p:cNvSpPr>
+          <p:nvPr>
+            <p:ph type="body" idx="1"/>
+          </p:nvPr>
+        </p:nvSpPr>
+        <p:spPr/>
+        <p:txBody>
+          <a:bodyPr/>
+          <a:lstStyle/>
+          <a:p>
+            <a:pPr lvl="0" indent="0" marL="0">
+              <a:buNone/>
+            </a:pPr>
+            <a:r>
+              <a:rPr/>
+              <a:t>Three experiments, one architecture. Frozen: embedding and decoder come from CBOW or from word2vec and are not trained; only the GRU and the small linear layer are. End to end: same layers, random initialisation, everything trained on the next-word task.</a:t>
+            </a:r>
+          </a:p>
+          <a:p>
+            <a:pPr lvl="0" indent="0" marL="0">
+              <a:buNone/>
+            </a:pPr>
+          </a:p>
+          <a:p>
+            <a:pPr lvl="0" indent="0" marL="0">
+              <a:buNone/>
+            </a:pPr>
+            <a:r>
+              <a:rPr/>
+              <a:t>One detail for word2vec: its decoder has no bias. With negative sampling, the score approximates log p(w | context) − log p(w), up to a constant, so we add the fixed bias log p(w), the frequency of each word. That turns the scores into log-probabilities without training anything.</a:t>
+            </a:r>
+          </a:p>
+        </p:txBody>
+      </p:sp>
+      <p:sp>
+        <p:nvSpPr>
+          <p:cNvPr id="4" name="Slide Number Placeholder 3"/>
+          <p:cNvSpPr>
+            <a:spLocks noGrp="1"/>
+          </p:cNvSpPr>
+          <p:nvPr>
+            <p:ph type="sldNum" sz="quarter" idx="10"/>
+          </p:nvPr>
+        </p:nvSpPr>
+        <p:spPr/>
+        <p:txBody>
+          <a:bodyPr/>
+          <a:lstStyle/>
+          <a:p>
+            <a:fld id="{18BDFEC3-8487-43E8-A154-7C12CBC1FFF2}" type="slidenum">
+              <a:rPr lang="en-US"/>
+              <a:t>36</a:t>
             </a:fld>
             <a:endParaRPr lang="en-US"/>
           </a:p>
@@ -7810,7 +7970,7 @@
             </a:pPr>
             <a:r>
               <a:rPr/>
-              <a:t>Gates: learned, soft switches</a:t>
+              <a:t>Gate: soft switch</a:t>
             </a:r>
           </a:p>
         </p:txBody>
@@ -7889,50 +8049,41 @@
             </a:pPr>
             <a:r>
               <a:rPr/>
-              <a:t>Three decisions at every step</a:t>
-            </a:r>
-          </a:p>
-        </p:txBody>
-      </p:sp>
-      <p:sp>
-        <p:nvSpPr>
-          <p:cNvPr id="3" name="Content Placeholder 2"/>
-          <p:cNvSpPr>
-            <a:spLocks noGrp="1"/>
-          </p:cNvSpPr>
-          <p:nvPr>
-            <p:ph idx="1"/>
-          </p:nvPr>
-        </p:nvSpPr>
-        <p:spPr/>
-        <p:txBody>
-          <a:bodyPr>
-            <a:normAutofit/>
-          </a:bodyPr>
-          <a:lstStyle/>
-          <a:p>
-            <a:pPr lvl="0"/>
-            <a:r>
-              <a:rPr/>
-              <a:t>Forget: what to erase from the memory?</a:t>
-            </a:r>
-          </a:p>
-          <a:p>
-            <a:pPr lvl="0"/>
-            <a:r>
-              <a:rPr/>
-              <a:t>Input: what new information to write?</a:t>
-            </a:r>
-          </a:p>
-          <a:p>
-            <a:pPr lvl="0"/>
-            <a:r>
-              <a:rPr/>
-              <a:t>Output: what to show from the memory?</a:t>
-            </a:r>
-          </a:p>
-        </p:txBody>
-      </p:sp>
+              <a:t>The LSTM cell</a:t>
+            </a:r>
+          </a:p>
+        </p:txBody>
+      </p:sp>
+      <p:pic>
+        <p:nvPicPr>
+          <p:cNvPr descr="img/lstm_cell.png" id="0" name="Picture 1"/>
+          <p:cNvPicPr>
+            <a:picLocks noGrp="1" noChangeAspect="1"/>
+          </p:cNvPicPr>
+          <p:nvPr/>
+        </p:nvPicPr>
+        <p:blipFill>
+          <a:blip r:embed="rId3"/>
+          <a:stretch>
+            <a:fillRect/>
+          </a:stretch>
+        </p:blipFill>
+        <p:spPr bwMode="auto">
+          <a:xfrm>
+            <a:off x="457200" y="1193800"/>
+            <a:ext cx="8229600" cy="3390900"/>
+          </a:xfrm>
+          <a:prstGeom prst="rect">
+            <a:avLst/>
+          </a:prstGeom>
+          <a:noFill/>
+          <a:ln w="9525">
+            <a:noFill/>
+            <a:headEnd/>
+            <a:tailEnd/>
+          </a:ln>
+        </p:spPr>
+      </p:pic>
     </p:spTree>
   </p:cSld>
 </p:sld>
@@ -8062,14 +8213,14 @@
             </a:pPr>
             <a:r>
               <a:rPr/>
-              <a:t>The LSTM cell</a:t>
+              <a:t>LSTM: the equations</a:t>
             </a:r>
           </a:p>
         </p:txBody>
       </p:sp>
       <p:pic>
         <p:nvPicPr>
-          <p:cNvPr descr="img/lstm_cell.png" id="0" name="Picture 1"/>
+          <p:cNvPr descr="img/lstm_equations.png" id="0" name="Picture 1"/>
           <p:cNvPicPr>
             <a:picLocks noGrp="1" noChangeAspect="1"/>
           </p:cNvPicPr>
@@ -8141,14 +8292,14 @@
             </a:pPr>
             <a:r>
               <a:rPr/>
-              <a:t>LSTM: the equations</a:t>
+              <a:t>Why the gradient survives</a:t>
             </a:r>
           </a:p>
         </p:txBody>
       </p:sp>
       <p:pic>
         <p:nvPicPr>
-          <p:cNvPr descr="img/lstm_equations.png" id="0" name="Picture 1"/>
+          <p:cNvPr descr="img/lstm_gradient.png" id="0" name="Picture 1"/>
           <p:cNvPicPr>
             <a:picLocks noGrp="1" noChangeAspect="1"/>
           </p:cNvPicPr>
@@ -8220,63 +8371,41 @@
             </a:pPr>
             <a:r>
               <a:rPr/>
-              <a:t>Why the gradient survives</a:t>
-            </a:r>
-          </a:p>
-        </p:txBody>
-      </p:sp>
-      <p:sp>
-        <p:nvSpPr>
-          <p:cNvPr id="3" name="Content Placeholder 2"/>
-          <p:cNvSpPr>
-            <a:spLocks noGrp="1"/>
-          </p:cNvSpPr>
-          <p:nvPr>
-            <p:ph idx="1"/>
-          </p:nvPr>
-        </p:nvSpPr>
-        <p:spPr/>
-        <p:txBody>
-          <a:bodyPr>
-            <a:normAutofit/>
-          </a:bodyPr>
-          <a:lstStyle/>
-          <a:p>
-            <a:pPr lvl="0" indent="0">
-              <a:buNone/>
-            </a:pPr>
-            <a:r>
-              <a:rPr>
-                <a:latin typeface="Courier"/>
-              </a:rPr>
-              <a:t>c_t = f_t * c_(t-1) + i_t * c~_t
-d c_t / d c_(t-1) = f_t
-</a:t>
-            </a:r>
-          </a:p>
-          <a:p>
-            <a:pPr lvl="0"/>
-            <a:r>
-              <a:rPr/>
-              <a:t>No W_hh, no tanh’ on the memory path</a:t>
-            </a:r>
-          </a:p>
-          <a:p>
-            <a:pPr lvl="0"/>
-            <a:r>
-              <a:rPr/>
-              <a:t>f ≈ 1: the gradient flows back unchanged</a:t>
-            </a:r>
-          </a:p>
-          <a:p>
-            <a:pPr lvl="0"/>
-            <a:r>
-              <a:rPr/>
-              <a:t>The network learns when to forget</a:t>
-            </a:r>
-          </a:p>
-        </p:txBody>
-      </p:sp>
+              <a:t>GRU: a simpler LSTM</a:t>
+            </a:r>
+          </a:p>
+        </p:txBody>
+      </p:sp>
+      <p:pic>
+        <p:nvPicPr>
+          <p:cNvPr descr="img/lstm_to_gru.png" id="0" name="Picture 1"/>
+          <p:cNvPicPr>
+            <a:picLocks noGrp="1" noChangeAspect="1"/>
+          </p:cNvPicPr>
+          <p:nvPr/>
+        </p:nvPicPr>
+        <p:blipFill>
+          <a:blip r:embed="rId3"/>
+          <a:stretch>
+            <a:fillRect/>
+          </a:stretch>
+        </p:blipFill>
+        <p:spPr bwMode="auto">
+          <a:xfrm>
+            <a:off x="457200" y="1193800"/>
+            <a:ext cx="8229600" cy="3390900"/>
+          </a:xfrm>
+          <a:prstGeom prst="rect">
+            <a:avLst/>
+          </a:prstGeom>
+          <a:noFill/>
+          <a:ln w="9525">
+            <a:noFill/>
+            <a:headEnd/>
+            <a:tailEnd/>
+          </a:ln>
+        </p:spPr>
+      </p:pic>
     </p:spTree>
   </p:cSld>
 </p:sld>
@@ -8321,14 +8450,14 @@
             </a:pPr>
             <a:r>
               <a:rPr/>
-              <a:t>GRU: a simpler LSTM</a:t>
+              <a:t>The GRU cell</a:t>
             </a:r>
           </a:p>
         </p:txBody>
       </p:sp>
       <p:pic>
         <p:nvPicPr>
-          <p:cNvPr descr="img/lstm_to_gru.png" id="0" name="Picture 1"/>
+          <p:cNvPr descr="img/gru_cell.png" id="0" name="Picture 1"/>
           <p:cNvPicPr>
             <a:picLocks noGrp="1" noChangeAspect="1"/>
           </p:cNvPicPr>
@@ -8479,536 +8608,14 @@
             </a:pPr>
             <a:r>
               <a:rPr/>
-              <a:t>LSTM and GRU in PyTorch</a:t>
-            </a:r>
-          </a:p>
-        </p:txBody>
-      </p:sp>
-      <p:sp>
-        <p:nvSpPr>
-          <p:cNvPr id="3" name="Content Placeholder 2"/>
-          <p:cNvSpPr>
-            <a:spLocks noGrp="1"/>
-          </p:cNvSpPr>
-          <p:nvPr>
-            <p:ph idx="1"/>
-          </p:nvPr>
-        </p:nvSpPr>
-        <p:spPr/>
-        <p:txBody>
-          <a:bodyPr>
-            <a:normAutofit/>
-          </a:bodyPr>
-          <a:lstStyle/>
-          <a:p>
-            <a:pPr lvl="0" indent="0">
-              <a:buNone/>
-            </a:pPr>
-            <a:r>
-              <a:rPr>
-                <a:latin typeface="Courier"/>
-              </a:rPr>
-              <a:t>x </a:t>
-            </a:r>
-            <a:r>
-              <a:rPr>
-                <a:solidFill>
-                  <a:srgbClr val="666666"/>
-                </a:solidFill>
-                <a:latin typeface="Courier"/>
-              </a:rPr>
-              <a:t>=</a:t>
-            </a:r>
-            <a:r>
-              <a:rPr>
-                <a:latin typeface="Courier"/>
-              </a:rPr>
-              <a:t> torch.randn(</a:t>
-            </a:r>
-            <a:r>
-              <a:rPr>
-                <a:solidFill>
-                  <a:srgbClr val="40A070"/>
-                </a:solidFill>
-                <a:latin typeface="Courier"/>
-              </a:rPr>
-              <a:t>64</a:t>
-            </a:r>
-            <a:r>
-              <a:rPr>
-                <a:latin typeface="Courier"/>
-              </a:rPr>
-              <a:t>, </a:t>
-            </a:r>
-            <a:r>
-              <a:rPr>
-                <a:solidFill>
-                  <a:srgbClr val="40A070"/>
-                </a:solidFill>
-                <a:latin typeface="Courier"/>
-              </a:rPr>
-              <a:t>32</a:t>
-            </a:r>
-            <a:r>
-              <a:rPr>
-                <a:latin typeface="Courier"/>
-              </a:rPr>
-              <a:t>, </a:t>
-            </a:r>
-            <a:r>
-              <a:rPr>
-                <a:solidFill>
-                  <a:srgbClr val="40A070"/>
-                </a:solidFill>
-                <a:latin typeface="Courier"/>
-              </a:rPr>
-              <a:t>100</a:t>
-            </a:r>
-            <a:r>
-              <a:rPr>
-                <a:latin typeface="Courier"/>
-              </a:rPr>
-              <a:t>)</a:t>
-            </a:r>
-            <a:br/>
-            <a:r>
-              <a:rPr>
-                <a:latin typeface="Courier"/>
-              </a:rPr>
-              <a:t>lstm </a:t>
-            </a:r>
-            <a:r>
-              <a:rPr>
-                <a:solidFill>
-                  <a:srgbClr val="666666"/>
-                </a:solidFill>
-                <a:latin typeface="Courier"/>
-              </a:rPr>
-              <a:t>=</a:t>
-            </a:r>
-            <a:r>
-              <a:rPr>
-                <a:latin typeface="Courier"/>
-              </a:rPr>
-              <a:t> nn.LSTM(</a:t>
-            </a:r>
-            <a:r>
-              <a:rPr>
-                <a:solidFill>
-                  <a:srgbClr val="40A070"/>
-                </a:solidFill>
-                <a:latin typeface="Courier"/>
-              </a:rPr>
-              <a:t>100</a:t>
-            </a:r>
-            <a:r>
-              <a:rPr>
-                <a:latin typeface="Courier"/>
-              </a:rPr>
-              <a:t>, </a:t>
-            </a:r>
-            <a:r>
-              <a:rPr>
-                <a:solidFill>
-                  <a:srgbClr val="40A070"/>
-                </a:solidFill>
-                <a:latin typeface="Courier"/>
-              </a:rPr>
-              <a:t>256</a:t>
-            </a:r>
-            <a:r>
-              <a:rPr>
-                <a:latin typeface="Courier"/>
-              </a:rPr>
-              <a:t>,</a:t>
-            </a:r>
-            <a:br/>
-            <a:r>
-              <a:rPr>
-                <a:latin typeface="Courier"/>
-              </a:rPr>
-              <a:t>               batch_first</a:t>
-            </a:r>
-            <a:r>
-              <a:rPr>
-                <a:solidFill>
-                  <a:srgbClr val="666666"/>
-                </a:solidFill>
-                <a:latin typeface="Courier"/>
-              </a:rPr>
-              <a:t>=</a:t>
-            </a:r>
-            <a:r>
-              <a:rPr>
-                <a:solidFill>
-                  <a:srgbClr val="19177C"/>
-                </a:solidFill>
-                <a:latin typeface="Courier"/>
-              </a:rPr>
-              <a:t>True</a:t>
-            </a:r>
-            <a:r>
-              <a:rPr>
-                <a:latin typeface="Courier"/>
-              </a:rPr>
-              <a:t>)</a:t>
-            </a:r>
-            <a:br/>
-            <a:r>
-              <a:rPr>
-                <a:latin typeface="Courier"/>
-              </a:rPr>
-              <a:t>gru </a:t>
-            </a:r>
-            <a:r>
-              <a:rPr>
-                <a:solidFill>
-                  <a:srgbClr val="666666"/>
-                </a:solidFill>
-                <a:latin typeface="Courier"/>
-              </a:rPr>
-              <a:t>=</a:t>
-            </a:r>
-            <a:r>
-              <a:rPr>
-                <a:latin typeface="Courier"/>
-              </a:rPr>
-              <a:t> nn.GRU(</a:t>
-            </a:r>
-            <a:r>
-              <a:rPr>
-                <a:solidFill>
-                  <a:srgbClr val="40A070"/>
-                </a:solidFill>
-                <a:latin typeface="Courier"/>
-              </a:rPr>
-              <a:t>100</a:t>
-            </a:r>
-            <a:r>
-              <a:rPr>
-                <a:latin typeface="Courier"/>
-              </a:rPr>
-              <a:t>, </a:t>
-            </a:r>
-            <a:r>
-              <a:rPr>
-                <a:solidFill>
-                  <a:srgbClr val="40A070"/>
-                </a:solidFill>
-                <a:latin typeface="Courier"/>
-              </a:rPr>
-              <a:t>256</a:t>
-            </a:r>
-            <a:r>
-              <a:rPr>
-                <a:latin typeface="Courier"/>
-              </a:rPr>
-              <a:t>,</a:t>
-            </a:r>
-            <a:br/>
-            <a:r>
-              <a:rPr>
-                <a:latin typeface="Courier"/>
-              </a:rPr>
-              <a:t>             batch_first</a:t>
-            </a:r>
-            <a:r>
-              <a:rPr>
-                <a:solidFill>
-                  <a:srgbClr val="666666"/>
-                </a:solidFill>
-                <a:latin typeface="Courier"/>
-              </a:rPr>
-              <a:t>=</a:t>
-            </a:r>
-            <a:r>
-              <a:rPr>
-                <a:solidFill>
-                  <a:srgbClr val="19177C"/>
-                </a:solidFill>
-                <a:latin typeface="Courier"/>
-              </a:rPr>
-              <a:t>True</a:t>
-            </a:r>
-            <a:r>
-              <a:rPr>
-                <a:latin typeface="Courier"/>
-              </a:rPr>
-              <a:t>)</a:t>
-            </a:r>
-            <a:br/>
-            <a:r>
-              <a:rPr>
-                <a:latin typeface="Courier"/>
-              </a:rPr>
-              <a:t>out, (h, c) </a:t>
-            </a:r>
-            <a:r>
-              <a:rPr>
-                <a:solidFill>
-                  <a:srgbClr val="666666"/>
-                </a:solidFill>
-                <a:latin typeface="Courier"/>
-              </a:rPr>
-              <a:t>=</a:t>
-            </a:r>
-            <a:r>
-              <a:rPr>
-                <a:latin typeface="Courier"/>
-              </a:rPr>
-              <a:t> lstm(x)</a:t>
-            </a:r>
-            <a:br/>
-            <a:r>
-              <a:rPr>
-                <a:latin typeface="Courier"/>
-              </a:rPr>
-              <a:t>out, h </a:t>
-            </a:r>
-            <a:r>
-              <a:rPr>
-                <a:solidFill>
-                  <a:srgbClr val="666666"/>
-                </a:solidFill>
-                <a:latin typeface="Courier"/>
-              </a:rPr>
-              <a:t>=</a:t>
-            </a:r>
-            <a:r>
-              <a:rPr>
-                <a:latin typeface="Courier"/>
-              </a:rPr>
-              <a:t> gru(x)</a:t>
-            </a:r>
-            <a:br/>
-            <a:r>
-              <a:rPr>
-                <a:latin typeface="Courier"/>
-              </a:rPr>
-              <a:t>lstm.weight_hh_l0.shape</a:t>
-            </a:r>
-            <a:br/>
-            <a:r>
-              <a:rPr>
-                <a:latin typeface="Courier"/>
-              </a:rPr>
-              <a:t>gru.weight_hh_l0.shape</a:t>
-            </a:r>
-          </a:p>
-        </p:txBody>
-      </p:sp>
-    </p:spTree>
-  </p:cSld>
-</p:sld>
-</file>
-
-<file path=ppt/slides/slide26.xml><?xml version="1.0" encoding="utf-8"?>
-<p:sld xmlns:a="http://schemas.openxmlformats.org/drawingml/2006/main" xmlns:r="http://schemas.openxmlformats.org/officeDocument/2006/relationships" xmlns:p="http://schemas.openxmlformats.org/presentationml/2006/main">
-  <p:cSld>
-    <p:spTree>
-      <p:nvGrpSpPr>
-        <p:cNvPr id="1" name=""/>
-        <p:cNvGrpSpPr/>
-        <p:nvPr/>
-      </p:nvGrpSpPr>
-      <p:grpSpPr>
-        <a:xfrm>
-          <a:off x="0" y="0"/>
-          <a:ext cx="0" cy="0"/>
-          <a:chOff x="0" y="0"/>
-          <a:chExt cx="0" cy="0"/>
-        </a:xfrm>
-      </p:grpSpPr>
-      <p:sp>
-        <p:nvSpPr>
-          <p:cNvPr id="2" name="Title 1"/>
-          <p:cNvSpPr>
-            <a:spLocks noGrp="1"/>
-          </p:cNvSpPr>
-          <p:nvPr>
-            <p:ph type="title"/>
-          </p:nvPr>
-        </p:nvSpPr>
-        <p:spPr/>
-        <p:txBody>
-          <a:bodyPr>
-            <a:normAutofit/>
-          </a:bodyPr>
-          <a:lstStyle/>
-          <a:p>
-            <a:pPr lvl="0" indent="0" marL="0">
-              <a:buNone/>
-            </a:pPr>
-            <a:r>
-              <a:rPr/>
-              <a:t>Two states, or one</a:t>
-            </a:r>
-          </a:p>
-        </p:txBody>
-      </p:sp>
-      <p:sp>
-        <p:nvSpPr>
-          <p:cNvPr id="3" name="Content Placeholder 2"/>
-          <p:cNvSpPr>
-            <a:spLocks noGrp="1"/>
-          </p:cNvSpPr>
-          <p:nvPr>
-            <p:ph idx="1"/>
-          </p:nvPr>
-        </p:nvSpPr>
-        <p:spPr/>
-        <p:txBody>
-          <a:bodyPr>
-            <a:normAutofit/>
-          </a:bodyPr>
-          <a:lstStyle/>
-          <a:p>
-            <a:pPr lvl="0" indent="0">
-              <a:buNone/>
-            </a:pPr>
-            <a:r>
-              <a:rPr>
-                <a:latin typeface="Courier"/>
-              </a:rPr>
-              <a:t>LSTM h, c: [1, 64, 256]
-LSTM W_hh: [1024, 256] (4 blocks)
-GRU  h:    [1, 64, 256]
-GRU  W_hh: [768, 256]  (3 blocks)
-</a:t>
-            </a:r>
-          </a:p>
-          <a:p>
-            <a:pPr lvl="0"/>
-            <a:r>
-              <a:rPr/>
-              <a:t>Parameters: LSTM 367k, GRU 275k, RNN 92k</a:t>
-            </a:r>
-          </a:p>
-          <a:p>
-            <a:pPr lvl="0"/>
-            <a:r>
-              <a:rPr/>
-              <a:t>Similar results: we use </a:t>
-            </a:r>
-            <a:r>
-              <a:rPr>
-                <a:latin typeface="Courier"/>
-              </a:rPr>
-              <a:t>nn.GRU</a:t>
-            </a:r>
-            <a:r>
-              <a:rPr/>
-              <a:t> today</a:t>
-            </a:r>
-          </a:p>
-        </p:txBody>
-      </p:sp>
-    </p:spTree>
-  </p:cSld>
-</p:sld>
-</file>
-
-<file path=ppt/slides/slide27.xml><?xml version="1.0" encoding="utf-8"?>
-<p:sld xmlns:a="http://schemas.openxmlformats.org/drawingml/2006/main" xmlns:r="http://schemas.openxmlformats.org/officeDocument/2006/relationships" xmlns:p="http://schemas.openxmlformats.org/presentationml/2006/main">
-  <p:cSld>
-    <p:spTree>
-      <p:nvGrpSpPr>
-        <p:cNvPr id="1" name=""/>
-        <p:cNvGrpSpPr/>
-        <p:nvPr/>
-      </p:nvGrpSpPr>
-      <p:grpSpPr>
-        <a:xfrm>
-          <a:off x="0" y="0"/>
-          <a:ext cx="0" cy="0"/>
-          <a:chOff x="0" y="0"/>
-          <a:chExt cx="0" cy="0"/>
-        </a:xfrm>
-      </p:grpSpPr>
-      <p:sp>
-        <p:nvSpPr>
-          <p:cNvPr id="2" name="Title 1"/>
-          <p:cNvSpPr>
-            <a:spLocks noGrp="1"/>
-          </p:cNvSpPr>
-          <p:nvPr>
-            <p:ph type="title"/>
-          </p:nvPr>
-        </p:nvSpPr>
-        <p:spPr>
-          <a:xfrm>
-            <a:off x="722313" y="3305176"/>
-            <a:ext cx="7772400" cy="1021556"/>
-          </a:xfrm>
-        </p:spPr>
-        <p:txBody>
-          <a:bodyPr>
-            <a:normAutofit/>
-          </a:bodyPr>
-          <a:lstStyle/>
-          <a:p>
-            <a:pPr lvl="0" indent="0" marL="0">
-              <a:buNone/>
-            </a:pPr>
-            <a:r>
-              <a:rPr/>
-              <a:t>Predicting the next word</a:t>
-            </a:r>
-          </a:p>
-        </p:txBody>
-      </p:sp>
-    </p:spTree>
-  </p:cSld>
-</p:sld>
-</file>
-
-<file path=ppt/slides/slide28.xml><?xml version="1.0" encoding="utf-8"?>
-<p:sld xmlns:a="http://schemas.openxmlformats.org/drawingml/2006/main" xmlns:r="http://schemas.openxmlformats.org/officeDocument/2006/relationships" xmlns:p="http://schemas.openxmlformats.org/presentationml/2006/main">
-  <p:cSld>
-    <p:spTree>
-      <p:nvGrpSpPr>
-        <p:cNvPr id="1" name=""/>
-        <p:cNvGrpSpPr/>
-        <p:nvPr/>
-      </p:nvGrpSpPr>
-      <p:grpSpPr>
-        <a:xfrm>
-          <a:off x="0" y="0"/>
-          <a:ext cx="0" cy="0"/>
-          <a:chOff x="0" y="0"/>
-          <a:chExt cx="0" cy="0"/>
-        </a:xfrm>
-      </p:grpSpPr>
-      <p:sp>
-        <p:nvSpPr>
-          <p:cNvPr id="2" name="Title 1"/>
-          <p:cNvSpPr>
-            <a:spLocks noGrp="1"/>
-          </p:cNvSpPr>
-          <p:nvPr>
-            <p:ph type="title"/>
-          </p:nvPr>
-        </p:nvSpPr>
-        <p:spPr/>
-        <p:txBody>
-          <a:bodyPr>
-            <a:normAutofit/>
-          </a:bodyPr>
-          <a:lstStyle/>
-          <a:p>
-            <a:pPr lvl="0" indent="0" marL="0">
-              <a:buNone/>
-            </a:pPr>
-            <a:r>
-              <a:rPr/>
-              <a:t>Language modelling</a:t>
+              <a:t>LSTM vs GRU: the cells</a:t>
             </a:r>
           </a:p>
         </p:txBody>
       </p:sp>
       <p:pic>
         <p:nvPicPr>
-          <p:cNvPr descr="img/lm_shift.png" id="0" name="Picture 1"/>
+          <p:cNvPr descr="img/lstm_vs_gru.png" id="0" name="Picture 1"/>
           <p:cNvPicPr>
             <a:picLocks noGrp="1" noChangeAspect="1"/>
           </p:cNvPicPr>
@@ -9041,6 +8648,542 @@
 </p:sld>
 </file>
 
+<file path=ppt/slides/slide26.xml><?xml version="1.0" encoding="utf-8"?>
+<p:sld xmlns:a="http://schemas.openxmlformats.org/drawingml/2006/main" xmlns:r="http://schemas.openxmlformats.org/officeDocument/2006/relationships" xmlns:p="http://schemas.openxmlformats.org/presentationml/2006/main">
+  <p:cSld>
+    <p:spTree>
+      <p:nvGrpSpPr>
+        <p:cNvPr id="1" name=""/>
+        <p:cNvGrpSpPr/>
+        <p:nvPr/>
+      </p:nvGrpSpPr>
+      <p:grpSpPr>
+        <a:xfrm>
+          <a:off x="0" y="0"/>
+          <a:ext cx="0" cy="0"/>
+          <a:chOff x="0" y="0"/>
+          <a:chExt cx="0" cy="0"/>
+        </a:xfrm>
+      </p:grpSpPr>
+      <p:sp>
+        <p:nvSpPr>
+          <p:cNvPr id="2" name="Title 1"/>
+          <p:cNvSpPr>
+            <a:spLocks noGrp="1"/>
+          </p:cNvSpPr>
+          <p:nvPr>
+            <p:ph type="title"/>
+          </p:nvPr>
+        </p:nvSpPr>
+        <p:spPr/>
+        <p:txBody>
+          <a:bodyPr>
+            <a:normAutofit/>
+          </a:bodyPr>
+          <a:lstStyle/>
+          <a:p>
+            <a:pPr lvl="0" indent="0" marL="0">
+              <a:buNone/>
+            </a:pPr>
+            <a:r>
+              <a:rPr/>
+              <a:t>LSTM vs GRU: the equations</a:t>
+            </a:r>
+          </a:p>
+        </p:txBody>
+      </p:sp>
+      <p:pic>
+        <p:nvPicPr>
+          <p:cNvPr descr="img/lstm_vs_gru_equations.png" id="0" name="Picture 1"/>
+          <p:cNvPicPr>
+            <a:picLocks noGrp="1" noChangeAspect="1"/>
+          </p:cNvPicPr>
+          <p:nvPr/>
+        </p:nvPicPr>
+        <p:blipFill>
+          <a:blip r:embed="rId3"/>
+          <a:stretch>
+            <a:fillRect/>
+          </a:stretch>
+        </p:blipFill>
+        <p:spPr bwMode="auto">
+          <a:xfrm>
+            <a:off x="457200" y="1193800"/>
+            <a:ext cx="8229600" cy="3390900"/>
+          </a:xfrm>
+          <a:prstGeom prst="rect">
+            <a:avLst/>
+          </a:prstGeom>
+          <a:noFill/>
+          <a:ln w="9525">
+            <a:noFill/>
+            <a:headEnd/>
+            <a:tailEnd/>
+          </a:ln>
+        </p:spPr>
+      </p:pic>
+    </p:spTree>
+  </p:cSld>
+</p:sld>
+</file>
+
+<file path=ppt/slides/slide27.xml><?xml version="1.0" encoding="utf-8"?>
+<p:sld xmlns:a="http://schemas.openxmlformats.org/drawingml/2006/main" xmlns:r="http://schemas.openxmlformats.org/officeDocument/2006/relationships" xmlns:p="http://schemas.openxmlformats.org/presentationml/2006/main">
+  <p:cSld>
+    <p:spTree>
+      <p:nvGrpSpPr>
+        <p:cNvPr id="1" name=""/>
+        <p:cNvGrpSpPr/>
+        <p:nvPr/>
+      </p:nvGrpSpPr>
+      <p:grpSpPr>
+        <a:xfrm>
+          <a:off x="0" y="0"/>
+          <a:ext cx="0" cy="0"/>
+          <a:chOff x="0" y="0"/>
+          <a:chExt cx="0" cy="0"/>
+        </a:xfrm>
+      </p:grpSpPr>
+      <p:sp>
+        <p:nvSpPr>
+          <p:cNvPr id="2" name="Title 1"/>
+          <p:cNvSpPr>
+            <a:spLocks noGrp="1"/>
+          </p:cNvSpPr>
+          <p:nvPr>
+            <p:ph type="title"/>
+          </p:nvPr>
+        </p:nvSpPr>
+        <p:spPr/>
+        <p:txBody>
+          <a:bodyPr>
+            <a:normAutofit/>
+          </a:bodyPr>
+          <a:lstStyle/>
+          <a:p>
+            <a:pPr lvl="0" indent="0" marL="0">
+              <a:buNone/>
+            </a:pPr>
+            <a:r>
+              <a:rPr/>
+              <a:t>LSTM and GRU in PyTorch</a:t>
+            </a:r>
+          </a:p>
+        </p:txBody>
+      </p:sp>
+      <p:sp>
+        <p:nvSpPr>
+          <p:cNvPr id="3" name="Content Placeholder 2"/>
+          <p:cNvSpPr>
+            <a:spLocks noGrp="1"/>
+          </p:cNvSpPr>
+          <p:nvPr>
+            <p:ph idx="1"/>
+          </p:nvPr>
+        </p:nvSpPr>
+        <p:spPr/>
+        <p:txBody>
+          <a:bodyPr>
+            <a:normAutofit/>
+          </a:bodyPr>
+          <a:lstStyle/>
+          <a:p>
+            <a:pPr lvl="0" indent="0">
+              <a:buNone/>
+            </a:pPr>
+            <a:r>
+              <a:rPr>
+                <a:latin typeface="Courier"/>
+              </a:rPr>
+              <a:t>x </a:t>
+            </a:r>
+            <a:r>
+              <a:rPr>
+                <a:solidFill>
+                  <a:srgbClr val="666666"/>
+                </a:solidFill>
+                <a:latin typeface="Courier"/>
+              </a:rPr>
+              <a:t>=</a:t>
+            </a:r>
+            <a:r>
+              <a:rPr>
+                <a:latin typeface="Courier"/>
+              </a:rPr>
+              <a:t> torch.randn(</a:t>
+            </a:r>
+            <a:r>
+              <a:rPr>
+                <a:solidFill>
+                  <a:srgbClr val="40A070"/>
+                </a:solidFill>
+                <a:latin typeface="Courier"/>
+              </a:rPr>
+              <a:t>64</a:t>
+            </a:r>
+            <a:r>
+              <a:rPr>
+                <a:latin typeface="Courier"/>
+              </a:rPr>
+              <a:t>, </a:t>
+            </a:r>
+            <a:r>
+              <a:rPr>
+                <a:solidFill>
+                  <a:srgbClr val="40A070"/>
+                </a:solidFill>
+                <a:latin typeface="Courier"/>
+              </a:rPr>
+              <a:t>32</a:t>
+            </a:r>
+            <a:r>
+              <a:rPr>
+                <a:latin typeface="Courier"/>
+              </a:rPr>
+              <a:t>, </a:t>
+            </a:r>
+            <a:r>
+              <a:rPr>
+                <a:solidFill>
+                  <a:srgbClr val="40A070"/>
+                </a:solidFill>
+                <a:latin typeface="Courier"/>
+              </a:rPr>
+              <a:t>100</a:t>
+            </a:r>
+            <a:r>
+              <a:rPr>
+                <a:latin typeface="Courier"/>
+              </a:rPr>
+              <a:t>)</a:t>
+            </a:r>
+            <a:br/>
+            <a:r>
+              <a:rPr>
+                <a:latin typeface="Courier"/>
+              </a:rPr>
+              <a:t>lstm </a:t>
+            </a:r>
+            <a:r>
+              <a:rPr>
+                <a:solidFill>
+                  <a:srgbClr val="666666"/>
+                </a:solidFill>
+                <a:latin typeface="Courier"/>
+              </a:rPr>
+              <a:t>=</a:t>
+            </a:r>
+            <a:r>
+              <a:rPr>
+                <a:latin typeface="Courier"/>
+              </a:rPr>
+              <a:t> nn.LSTM(</a:t>
+            </a:r>
+            <a:r>
+              <a:rPr>
+                <a:solidFill>
+                  <a:srgbClr val="40A070"/>
+                </a:solidFill>
+                <a:latin typeface="Courier"/>
+              </a:rPr>
+              <a:t>100</a:t>
+            </a:r>
+            <a:r>
+              <a:rPr>
+                <a:latin typeface="Courier"/>
+              </a:rPr>
+              <a:t>, </a:t>
+            </a:r>
+            <a:r>
+              <a:rPr>
+                <a:solidFill>
+                  <a:srgbClr val="40A070"/>
+                </a:solidFill>
+                <a:latin typeface="Courier"/>
+              </a:rPr>
+              <a:t>256</a:t>
+            </a:r>
+            <a:r>
+              <a:rPr>
+                <a:latin typeface="Courier"/>
+              </a:rPr>
+              <a:t>,</a:t>
+            </a:r>
+            <a:br/>
+            <a:r>
+              <a:rPr>
+                <a:latin typeface="Courier"/>
+              </a:rPr>
+              <a:t>               batch_first</a:t>
+            </a:r>
+            <a:r>
+              <a:rPr>
+                <a:solidFill>
+                  <a:srgbClr val="666666"/>
+                </a:solidFill>
+                <a:latin typeface="Courier"/>
+              </a:rPr>
+              <a:t>=</a:t>
+            </a:r>
+            <a:r>
+              <a:rPr>
+                <a:solidFill>
+                  <a:srgbClr val="19177C"/>
+                </a:solidFill>
+                <a:latin typeface="Courier"/>
+              </a:rPr>
+              <a:t>True</a:t>
+            </a:r>
+            <a:r>
+              <a:rPr>
+                <a:latin typeface="Courier"/>
+              </a:rPr>
+              <a:t>)</a:t>
+            </a:r>
+            <a:br/>
+            <a:r>
+              <a:rPr>
+                <a:latin typeface="Courier"/>
+              </a:rPr>
+              <a:t>gru </a:t>
+            </a:r>
+            <a:r>
+              <a:rPr>
+                <a:solidFill>
+                  <a:srgbClr val="666666"/>
+                </a:solidFill>
+                <a:latin typeface="Courier"/>
+              </a:rPr>
+              <a:t>=</a:t>
+            </a:r>
+            <a:r>
+              <a:rPr>
+                <a:latin typeface="Courier"/>
+              </a:rPr>
+              <a:t> nn.GRU(</a:t>
+            </a:r>
+            <a:r>
+              <a:rPr>
+                <a:solidFill>
+                  <a:srgbClr val="40A070"/>
+                </a:solidFill>
+                <a:latin typeface="Courier"/>
+              </a:rPr>
+              <a:t>100</a:t>
+            </a:r>
+            <a:r>
+              <a:rPr>
+                <a:latin typeface="Courier"/>
+              </a:rPr>
+              <a:t>, </a:t>
+            </a:r>
+            <a:r>
+              <a:rPr>
+                <a:solidFill>
+                  <a:srgbClr val="40A070"/>
+                </a:solidFill>
+                <a:latin typeface="Courier"/>
+              </a:rPr>
+              <a:t>256</a:t>
+            </a:r>
+            <a:r>
+              <a:rPr>
+                <a:latin typeface="Courier"/>
+              </a:rPr>
+              <a:t>,</a:t>
+            </a:r>
+            <a:br/>
+            <a:r>
+              <a:rPr>
+                <a:latin typeface="Courier"/>
+              </a:rPr>
+              <a:t>             batch_first</a:t>
+            </a:r>
+            <a:r>
+              <a:rPr>
+                <a:solidFill>
+                  <a:srgbClr val="666666"/>
+                </a:solidFill>
+                <a:latin typeface="Courier"/>
+              </a:rPr>
+              <a:t>=</a:t>
+            </a:r>
+            <a:r>
+              <a:rPr>
+                <a:solidFill>
+                  <a:srgbClr val="19177C"/>
+                </a:solidFill>
+                <a:latin typeface="Courier"/>
+              </a:rPr>
+              <a:t>True</a:t>
+            </a:r>
+            <a:r>
+              <a:rPr>
+                <a:latin typeface="Courier"/>
+              </a:rPr>
+              <a:t>)</a:t>
+            </a:r>
+            <a:br/>
+            <a:r>
+              <a:rPr>
+                <a:latin typeface="Courier"/>
+              </a:rPr>
+              <a:t>out, (h, c) </a:t>
+            </a:r>
+            <a:r>
+              <a:rPr>
+                <a:solidFill>
+                  <a:srgbClr val="666666"/>
+                </a:solidFill>
+                <a:latin typeface="Courier"/>
+              </a:rPr>
+              <a:t>=</a:t>
+            </a:r>
+            <a:r>
+              <a:rPr>
+                <a:latin typeface="Courier"/>
+              </a:rPr>
+              <a:t> lstm(x)</a:t>
+            </a:r>
+            <a:br/>
+            <a:r>
+              <a:rPr>
+                <a:latin typeface="Courier"/>
+              </a:rPr>
+              <a:t>out, h </a:t>
+            </a:r>
+            <a:r>
+              <a:rPr>
+                <a:solidFill>
+                  <a:srgbClr val="666666"/>
+                </a:solidFill>
+                <a:latin typeface="Courier"/>
+              </a:rPr>
+              <a:t>=</a:t>
+            </a:r>
+            <a:r>
+              <a:rPr>
+                <a:latin typeface="Courier"/>
+              </a:rPr>
+              <a:t> gru(x)</a:t>
+            </a:r>
+            <a:br/>
+            <a:br/>
+            <a:r>
+              <a:rPr i="1">
+                <a:solidFill>
+                  <a:srgbClr val="60A0B0"/>
+                </a:solidFill>
+                <a:latin typeface="Courier"/>
+              </a:rPr>
+              <a:t># LSTM h, c: [1, 64, 256]</a:t>
+            </a:r>
+            <a:br/>
+            <a:r>
+              <a:rPr i="1">
+                <a:solidFill>
+                  <a:srgbClr val="60A0B0"/>
+                </a:solidFill>
+                <a:latin typeface="Courier"/>
+              </a:rPr>
+              <a:t># LSTM W_hh: [1024, 256] (4 blocks)</a:t>
+            </a:r>
+            <a:br/>
+            <a:r>
+              <a:rPr i="1">
+                <a:solidFill>
+                  <a:srgbClr val="60A0B0"/>
+                </a:solidFill>
+                <a:latin typeface="Courier"/>
+              </a:rPr>
+              <a:t># GRU  h:    [1, 64, 256]</a:t>
+            </a:r>
+            <a:br/>
+            <a:r>
+              <a:rPr i="1">
+                <a:solidFill>
+                  <a:srgbClr val="60A0B0"/>
+                </a:solidFill>
+                <a:latin typeface="Courier"/>
+              </a:rPr>
+              <a:t># GRU  W_hh: [768, 256]  (3 blocks)</a:t>
+            </a:r>
+          </a:p>
+          <a:p>
+            <a:pPr lvl="0"/>
+            <a:r>
+              <a:rPr/>
+              <a:t>Parameters: LSTM 367k, GRU 275k, RNN 92k</a:t>
+            </a:r>
+          </a:p>
+          <a:p>
+            <a:pPr lvl="0"/>
+            <a:r>
+              <a:rPr/>
+              <a:t>LSTM &amp; GRU usually show results</a:t>
+            </a:r>
+          </a:p>
+        </p:txBody>
+      </p:sp>
+    </p:spTree>
+  </p:cSld>
+</p:sld>
+</file>
+
+<file path=ppt/slides/slide28.xml><?xml version="1.0" encoding="utf-8"?>
+<p:sld xmlns:a="http://schemas.openxmlformats.org/drawingml/2006/main" xmlns:r="http://schemas.openxmlformats.org/officeDocument/2006/relationships" xmlns:p="http://schemas.openxmlformats.org/presentationml/2006/main">
+  <p:cSld>
+    <p:spTree>
+      <p:nvGrpSpPr>
+        <p:cNvPr id="1" name=""/>
+        <p:cNvGrpSpPr/>
+        <p:nvPr/>
+      </p:nvGrpSpPr>
+      <p:grpSpPr>
+        <a:xfrm>
+          <a:off x="0" y="0"/>
+          <a:ext cx="0" cy="0"/>
+          <a:chOff x="0" y="0"/>
+          <a:chExt cx="0" cy="0"/>
+        </a:xfrm>
+      </p:grpSpPr>
+      <p:sp>
+        <p:nvSpPr>
+          <p:cNvPr id="2" name="Title 1"/>
+          <p:cNvSpPr>
+            <a:spLocks noGrp="1"/>
+          </p:cNvSpPr>
+          <p:nvPr>
+            <p:ph type="title"/>
+          </p:nvPr>
+        </p:nvSpPr>
+        <p:spPr>
+          <a:xfrm>
+            <a:off x="722313" y="3305176"/>
+            <a:ext cx="7772400" cy="1021556"/>
+          </a:xfrm>
+        </p:spPr>
+        <p:txBody>
+          <a:bodyPr>
+            <a:normAutofit/>
+          </a:bodyPr>
+          <a:lstStyle/>
+          <a:p>
+            <a:pPr lvl="0" indent="0" marL="0">
+              <a:buNone/>
+            </a:pPr>
+            <a:r>
+              <a:rPr/>
+              <a:t>Predicting the next word</a:t>
+            </a:r>
+          </a:p>
+        </p:txBody>
+      </p:sp>
+    </p:spTree>
+  </p:cSld>
+</p:sld>
+</file>
+
 <file path=ppt/slides/slide29.xml><?xml version="1.0" encoding="utf-8"?>
 <p:sld xmlns:a="http://schemas.openxmlformats.org/drawingml/2006/main" xmlns:r="http://schemas.openxmlformats.org/officeDocument/2006/relationships" xmlns:p="http://schemas.openxmlformats.org/presentationml/2006/main">
   <p:cSld>
@@ -9080,62 +9223,41 @@
             </a:pPr>
             <a:r>
               <a:rPr/>
-              <a:t>Measuring it: perplexity</a:t>
-            </a:r>
-          </a:p>
-        </p:txBody>
-      </p:sp>
-      <p:sp>
-        <p:nvSpPr>
-          <p:cNvPr id="3" name="Content Placeholder 2"/>
-          <p:cNvSpPr>
-            <a:spLocks noGrp="1"/>
-          </p:cNvSpPr>
-          <p:nvPr>
-            <p:ph idx="1"/>
-          </p:nvPr>
-        </p:nvSpPr>
-        <p:spPr/>
-        <p:txBody>
-          <a:bodyPr>
-            <a:normAutofit/>
-          </a:bodyPr>
-          <a:lstStyle/>
-          <a:p>
-            <a:pPr lvl="0" indent="0">
-              <a:buNone/>
-            </a:pPr>
-            <a:r>
-              <a:rPr>
-                <a:latin typeface="Courier"/>
-              </a:rPr>
-              <a:t>perplexity = exp(cross-entropy)
-</a:t>
-            </a:r>
-          </a:p>
-          <a:p>
-            <a:pPr lvl="0"/>
-            <a:r>
-              <a:rPr/>
-              <a:t>How many words the model hesitates between</a:t>
-            </a:r>
-          </a:p>
-          <a:p>
-            <a:pPr lvl="0"/>
-            <a:r>
-              <a:rPr/>
-              <a:t>Uniform guess over 10 001 words: 10 001</a:t>
-            </a:r>
-          </a:p>
-          <a:p>
-            <a:pPr lvl="0"/>
-            <a:r>
-              <a:rPr/>
-              <a:t>Perfect model: 1</a:t>
-            </a:r>
-          </a:p>
-        </p:txBody>
-      </p:sp>
+              <a:t>Language modelling</a:t>
+            </a:r>
+          </a:p>
+        </p:txBody>
+      </p:sp>
+      <p:pic>
+        <p:nvPicPr>
+          <p:cNvPr descr="img/lm_shift.png" id="0" name="Picture 1"/>
+          <p:cNvPicPr>
+            <a:picLocks noGrp="1" noChangeAspect="1"/>
+          </p:cNvPicPr>
+          <p:nvPr/>
+        </p:nvPicPr>
+        <p:blipFill>
+          <a:blip r:embed="rId3"/>
+          <a:stretch>
+            <a:fillRect/>
+          </a:stretch>
+        </p:blipFill>
+        <p:spPr bwMode="auto">
+          <a:xfrm>
+            <a:off x="457200" y="1193800"/>
+            <a:ext cx="8229600" cy="3390900"/>
+          </a:xfrm>
+          <a:prstGeom prst="rect">
+            <a:avLst/>
+          </a:prstGeom>
+          <a:noFill/>
+          <a:ln w="9525">
+            <a:noFill/>
+            <a:headEnd/>
+            <a:tailEnd/>
+          </a:ln>
+        </p:spPr>
+      </p:pic>
     </p:spTree>
   </p:cSld>
 </p:sld>
@@ -9259,7 +9381,7 @@
             </a:pPr>
             <a:r>
               <a:rPr/>
-              <a:t>RNN: one-hot encodings vs embeddings</a:t>
+              <a:t>Perplexity</a:t>
             </a:r>
           </a:p>
         </p:txBody>
@@ -9285,414 +9407,32 @@
               <a:buNone/>
             </a:pPr>
             <a:r>
-              <a:rPr b="1">
-                <a:solidFill>
-                  <a:srgbClr val="007020"/>
-                </a:solidFill>
-                <a:latin typeface="Courier"/>
-              </a:rPr>
-              <a:t>def</a:t>
-            </a:r>
-            <a:r>
-              <a:rPr>
-                <a:latin typeface="Courier"/>
-              </a:rPr>
-              <a:t> n_params(</a:t>
-            </a:r>
-            <a:r>
-              <a:rPr>
-                <a:solidFill>
-                  <a:srgbClr val="666666"/>
-                </a:solidFill>
-                <a:latin typeface="Courier"/>
-              </a:rPr>
-              <a:t>*</a:t>
-            </a:r>
-            <a:r>
-              <a:rPr>
-                <a:latin typeface="Courier"/>
-              </a:rPr>
-              <a:t>modules):</a:t>
-            </a:r>
-            <a:br/>
-            <a:r>
-              <a:rPr>
-                <a:latin typeface="Courier"/>
-              </a:rPr>
-              <a:t>    </a:t>
-            </a:r>
-            <a:r>
-              <a:rPr b="1">
-                <a:solidFill>
-                  <a:srgbClr val="007020"/>
-                </a:solidFill>
-                <a:latin typeface="Courier"/>
-              </a:rPr>
-              <a:t>return</a:t>
-            </a:r>
-            <a:r>
-              <a:rPr>
-                <a:latin typeface="Courier"/>
-              </a:rPr>
-              <a:t> </a:t>
-            </a:r>
-            <a:r>
-              <a:rPr>
-                <a:solidFill>
-                  <a:srgbClr val="008000"/>
-                </a:solidFill>
-                <a:latin typeface="Courier"/>
-              </a:rPr>
-              <a:t>sum</a:t>
-            </a:r>
-            <a:r>
-              <a:rPr>
-                <a:latin typeface="Courier"/>
-              </a:rPr>
-              <a:t>(p.numel() </a:t>
-            </a:r>
-            <a:r>
-              <a:rPr b="1">
-                <a:solidFill>
-                  <a:srgbClr val="007020"/>
-                </a:solidFill>
-                <a:latin typeface="Courier"/>
-              </a:rPr>
-              <a:t>for</a:t>
-            </a:r>
-            <a:r>
-              <a:rPr>
-                <a:latin typeface="Courier"/>
-              </a:rPr>
-              <a:t> m </a:t>
-            </a:r>
-            <a:r>
-              <a:rPr b="1">
-                <a:solidFill>
-                  <a:srgbClr val="007020"/>
-                </a:solidFill>
-                <a:latin typeface="Courier"/>
-              </a:rPr>
-              <a:t>in</a:t>
-            </a:r>
-            <a:r>
-              <a:rPr>
-                <a:latin typeface="Courier"/>
-              </a:rPr>
-              <a:t> modules</a:t>
-            </a:r>
-            <a:br/>
-            <a:r>
-              <a:rPr>
-                <a:latin typeface="Courier"/>
-              </a:rPr>
-              <a:t>               </a:t>
-            </a:r>
-            <a:r>
-              <a:rPr b="1">
-                <a:solidFill>
-                  <a:srgbClr val="007020"/>
-                </a:solidFill>
-                <a:latin typeface="Courier"/>
-              </a:rPr>
-              <a:t>for</a:t>
-            </a:r>
-            <a:r>
-              <a:rPr>
-                <a:latin typeface="Courier"/>
-              </a:rPr>
-              <a:t> p </a:t>
-            </a:r>
-            <a:r>
-              <a:rPr b="1">
-                <a:solidFill>
-                  <a:srgbClr val="007020"/>
-                </a:solidFill>
-                <a:latin typeface="Courier"/>
-              </a:rPr>
-              <a:t>in</a:t>
-            </a:r>
-            <a:r>
-              <a:rPr>
-                <a:latin typeface="Courier"/>
-              </a:rPr>
-              <a:t> m.parameters())</a:t>
-            </a:r>
-            <a:br/>
-            <a:br/>
-            <a:r>
-              <a:rPr>
-                <a:latin typeface="Courier"/>
-              </a:rPr>
-              <a:t>V </a:t>
-            </a:r>
-            <a:r>
-              <a:rPr>
-                <a:solidFill>
-                  <a:srgbClr val="666666"/>
-                </a:solidFill>
-                <a:latin typeface="Courier"/>
-              </a:rPr>
-              <a:t>=</a:t>
-            </a:r>
-            <a:r>
-              <a:rPr>
-                <a:latin typeface="Courier"/>
-              </a:rPr>
-              <a:t> </a:t>
-            </a:r>
-            <a:r>
-              <a:rPr>
-                <a:solidFill>
-                  <a:srgbClr val="40A070"/>
-                </a:solidFill>
-                <a:latin typeface="Courier"/>
-              </a:rPr>
-              <a:t>10_001</a:t>
-            </a:r>
-            <a:r>
-              <a:rPr>
-                <a:latin typeface="Courier"/>
-              </a:rPr>
-              <a:t>  </a:t>
-            </a:r>
-            <a:r>
-              <a:rPr i="1">
-                <a:solidFill>
-                  <a:srgbClr val="60A0B0"/>
-                </a:solidFill>
-                <a:latin typeface="Courier"/>
-              </a:rPr>
-              <a:t># vocabulary size</a:t>
-            </a:r>
-            <a:br/>
-            <a:r>
-              <a:rPr>
-                <a:latin typeface="Courier"/>
-              </a:rPr>
-              <a:t>one_hot </a:t>
-            </a:r>
-            <a:r>
-              <a:rPr>
-                <a:solidFill>
-                  <a:srgbClr val="666666"/>
-                </a:solidFill>
-                <a:latin typeface="Courier"/>
-              </a:rPr>
-              <a:t>=</a:t>
-            </a:r>
-            <a:r>
-              <a:rPr>
-                <a:latin typeface="Courier"/>
-              </a:rPr>
-              <a:t> [nn.GRU(V, </a:t>
-            </a:r>
-            <a:r>
-              <a:rPr>
-                <a:solidFill>
-                  <a:srgbClr val="40A070"/>
-                </a:solidFill>
-                <a:latin typeface="Courier"/>
-              </a:rPr>
-              <a:t>256</a:t>
-            </a:r>
-            <a:r>
-              <a:rPr>
-                <a:latin typeface="Courier"/>
-              </a:rPr>
-              <a:t>),</a:t>
-            </a:r>
-            <a:br/>
-            <a:r>
-              <a:rPr>
-                <a:latin typeface="Courier"/>
-              </a:rPr>
-              <a:t>           nn.Linear(</a:t>
-            </a:r>
-            <a:r>
-              <a:rPr>
-                <a:solidFill>
-                  <a:srgbClr val="40A070"/>
-                </a:solidFill>
-                <a:latin typeface="Courier"/>
-              </a:rPr>
-              <a:t>256</a:t>
-            </a:r>
-            <a:r>
-              <a:rPr>
-                <a:latin typeface="Courier"/>
-              </a:rPr>
-              <a:t>, V)]</a:t>
-            </a:r>
-            <a:br/>
-            <a:r>
-              <a:rPr>
-                <a:latin typeface="Courier"/>
-              </a:rPr>
-              <a:t>embedded </a:t>
-            </a:r>
-            <a:r>
-              <a:rPr>
-                <a:solidFill>
-                  <a:srgbClr val="666666"/>
-                </a:solidFill>
-                <a:latin typeface="Courier"/>
-              </a:rPr>
-              <a:t>=</a:t>
-            </a:r>
-            <a:r>
-              <a:rPr>
-                <a:latin typeface="Courier"/>
-              </a:rPr>
-              <a:t> [nn.Embedding(V, </a:t>
-            </a:r>
-            <a:r>
-              <a:rPr>
-                <a:solidFill>
-                  <a:srgbClr val="40A070"/>
-                </a:solidFill>
-                <a:latin typeface="Courier"/>
-              </a:rPr>
-              <a:t>100</a:t>
-            </a:r>
-            <a:r>
-              <a:rPr>
-                <a:latin typeface="Courier"/>
-              </a:rPr>
-              <a:t>),</a:t>
-            </a:r>
-            <a:br/>
-            <a:r>
-              <a:rPr>
-                <a:latin typeface="Courier"/>
-              </a:rPr>
-              <a:t>            nn.GRU(</a:t>
-            </a:r>
-            <a:r>
-              <a:rPr>
-                <a:solidFill>
-                  <a:srgbClr val="40A070"/>
-                </a:solidFill>
-                <a:latin typeface="Courier"/>
-              </a:rPr>
-              <a:t>100</a:t>
-            </a:r>
-            <a:r>
-              <a:rPr>
-                <a:latin typeface="Courier"/>
-              </a:rPr>
-              <a:t>, </a:t>
-            </a:r>
-            <a:r>
-              <a:rPr>
-                <a:solidFill>
-                  <a:srgbClr val="40A070"/>
-                </a:solidFill>
-                <a:latin typeface="Courier"/>
-              </a:rPr>
-              <a:t>256</a:t>
-            </a:r>
-            <a:r>
-              <a:rPr>
-                <a:latin typeface="Courier"/>
-              </a:rPr>
-              <a:t>),</a:t>
-            </a:r>
-            <a:br/>
-            <a:r>
-              <a:rPr>
-                <a:latin typeface="Courier"/>
-              </a:rPr>
-              <a:t>            nn.Linear(</a:t>
-            </a:r>
-            <a:r>
-              <a:rPr>
-                <a:solidFill>
-                  <a:srgbClr val="40A070"/>
-                </a:solidFill>
-                <a:latin typeface="Courier"/>
-              </a:rPr>
-              <a:t>256</a:t>
-            </a:r>
-            <a:r>
-              <a:rPr>
-                <a:latin typeface="Courier"/>
-              </a:rPr>
-              <a:t>, </a:t>
-            </a:r>
-            <a:r>
-              <a:rPr>
-                <a:solidFill>
-                  <a:srgbClr val="40A070"/>
-                </a:solidFill>
-                <a:latin typeface="Courier"/>
-              </a:rPr>
-              <a:t>100</a:t>
-            </a:r>
-            <a:r>
-              <a:rPr>
-                <a:latin typeface="Courier"/>
-              </a:rPr>
-              <a:t>),</a:t>
-            </a:r>
-            <a:br/>
-            <a:r>
-              <a:rPr>
-                <a:latin typeface="Courier"/>
-              </a:rPr>
-              <a:t>            nn.Linear(</a:t>
-            </a:r>
-            <a:r>
-              <a:rPr>
-                <a:solidFill>
-                  <a:srgbClr val="40A070"/>
-                </a:solidFill>
-                <a:latin typeface="Courier"/>
-              </a:rPr>
-              <a:t>100</a:t>
-            </a:r>
-            <a:r>
-              <a:rPr>
-                <a:latin typeface="Courier"/>
-              </a:rPr>
-              <a:t>, V)]</a:t>
-            </a:r>
-            <a:br/>
-            <a:r>
-              <a:rPr>
-                <a:latin typeface="Courier"/>
-              </a:rPr>
-              <a:t>n_params(</a:t>
-            </a:r>
-            <a:r>
-              <a:rPr>
-                <a:solidFill>
-                  <a:srgbClr val="666666"/>
-                </a:solidFill>
-                <a:latin typeface="Courier"/>
-              </a:rPr>
-              <a:t>*</a:t>
-            </a:r>
-            <a:r>
-              <a:rPr>
-                <a:latin typeface="Courier"/>
-              </a:rPr>
-              <a:t>one_hot), n_params(</a:t>
-            </a:r>
-            <a:r>
-              <a:rPr>
-                <a:solidFill>
-                  <a:srgbClr val="666666"/>
-                </a:solidFill>
-                <a:latin typeface="Courier"/>
-              </a:rPr>
-              <a:t>*</a:t>
-            </a:r>
-            <a:r>
-              <a:rPr>
-                <a:latin typeface="Courier"/>
-              </a:rPr>
-              <a:t>embedded)</a:t>
+              <a:rPr>
+                <a:latin typeface="Courier"/>
+              </a:rPr>
+              <a:t>perplexity = exp(cross-entropy)
+</a:t>
+            </a:r>
+          </a:p>
+          <a:p>
+            <a:pPr lvl="0"/>
+            <a:r>
+              <a:rPr/>
+              <a:t>How many words the model hesitates between</a:t>
+            </a:r>
+          </a:p>
+          <a:p>
+            <a:pPr lvl="0"/>
+            <a:r>
+              <a:rPr/>
+              <a:t>Uniform guess over 10 001 words: 10 001</a:t>
+            </a:r>
+          </a:p>
+          <a:p>
+            <a:pPr lvl="0"/>
+            <a:r>
+              <a:rPr/>
+              <a:t>Perfect model: 1</a:t>
             </a:r>
           </a:p>
         </p:txBody>
@@ -9741,14 +9481,14 @@
             </a:pPr>
             <a:r>
               <a:rPr/>
-              <a:t>RNN: one-hot encodings vs embeddings</a:t>
+              <a:t>Perplexity</a:t>
             </a:r>
           </a:p>
         </p:txBody>
       </p:sp>
       <p:pic>
         <p:nvPicPr>
-          <p:cNvPr descr="img/onehot_cost.png" id="0" name="Picture 1"/>
+          <p:cNvPr descr="img/perplexity.png" id="0" name="Picture 1"/>
           <p:cNvPicPr>
             <a:picLocks noGrp="1" noChangeAspect="1"/>
           </p:cNvPicPr>
@@ -9820,14 +9560,14 @@
             </a:pPr>
             <a:r>
               <a:rPr/>
-              <a:t>Embedding of one-hot selects a column</a:t>
+              <a:t>RNN: one-hot encodings vs embeddings</a:t>
             </a:r>
           </a:p>
         </p:txBody>
       </p:sp>
       <p:pic>
         <p:nvPicPr>
-          <p:cNvPr descr="img/onehot_select.png" id="0" name="Picture 1"/>
+          <p:cNvPr descr="img/onehot_cost.png" id="0" name="Picture 1"/>
           <p:cNvPicPr>
             <a:picLocks noGrp="1" noChangeAspect="1"/>
           </p:cNvPicPr>
@@ -9899,6 +9639,567 @@
             </a:pPr>
             <a:r>
               <a:rPr/>
+              <a:t>RNN: one-hot encodings vs embeddings</a:t>
+            </a:r>
+          </a:p>
+        </p:txBody>
+      </p:sp>
+      <p:sp>
+        <p:nvSpPr>
+          <p:cNvPr id="3" name="Content Placeholder 2"/>
+          <p:cNvSpPr>
+            <a:spLocks noGrp="1"/>
+          </p:cNvSpPr>
+          <p:nvPr>
+            <p:ph idx="1"/>
+          </p:nvPr>
+        </p:nvSpPr>
+        <p:spPr/>
+        <p:txBody>
+          <a:bodyPr>
+            <a:normAutofit/>
+          </a:bodyPr>
+          <a:lstStyle/>
+          <a:p>
+            <a:pPr lvl="0" indent="0">
+              <a:buNone/>
+            </a:pPr>
+            <a:r>
+              <a:rPr b="1">
+                <a:solidFill>
+                  <a:srgbClr val="007020"/>
+                </a:solidFill>
+                <a:latin typeface="Courier"/>
+              </a:rPr>
+              <a:t>def</a:t>
+            </a:r>
+            <a:r>
+              <a:rPr>
+                <a:latin typeface="Courier"/>
+              </a:rPr>
+              <a:t> n_params(</a:t>
+            </a:r>
+            <a:r>
+              <a:rPr>
+                <a:solidFill>
+                  <a:srgbClr val="666666"/>
+                </a:solidFill>
+                <a:latin typeface="Courier"/>
+              </a:rPr>
+              <a:t>*</a:t>
+            </a:r>
+            <a:r>
+              <a:rPr>
+                <a:latin typeface="Courier"/>
+              </a:rPr>
+              <a:t>modules):</a:t>
+            </a:r>
+            <a:br/>
+            <a:r>
+              <a:rPr>
+                <a:latin typeface="Courier"/>
+              </a:rPr>
+              <a:t>    </a:t>
+            </a:r>
+            <a:r>
+              <a:rPr b="1">
+                <a:solidFill>
+                  <a:srgbClr val="007020"/>
+                </a:solidFill>
+                <a:latin typeface="Courier"/>
+              </a:rPr>
+              <a:t>return</a:t>
+            </a:r>
+            <a:r>
+              <a:rPr>
+                <a:latin typeface="Courier"/>
+              </a:rPr>
+              <a:t> </a:t>
+            </a:r>
+            <a:r>
+              <a:rPr>
+                <a:solidFill>
+                  <a:srgbClr val="008000"/>
+                </a:solidFill>
+                <a:latin typeface="Courier"/>
+              </a:rPr>
+              <a:t>sum</a:t>
+            </a:r>
+            <a:r>
+              <a:rPr>
+                <a:latin typeface="Courier"/>
+              </a:rPr>
+              <a:t>(p.numel() </a:t>
+            </a:r>
+            <a:r>
+              <a:rPr b="1">
+                <a:solidFill>
+                  <a:srgbClr val="007020"/>
+                </a:solidFill>
+                <a:latin typeface="Courier"/>
+              </a:rPr>
+              <a:t>for</a:t>
+            </a:r>
+            <a:r>
+              <a:rPr>
+                <a:latin typeface="Courier"/>
+              </a:rPr>
+              <a:t> m </a:t>
+            </a:r>
+            <a:r>
+              <a:rPr b="1">
+                <a:solidFill>
+                  <a:srgbClr val="007020"/>
+                </a:solidFill>
+                <a:latin typeface="Courier"/>
+              </a:rPr>
+              <a:t>in</a:t>
+            </a:r>
+            <a:r>
+              <a:rPr>
+                <a:latin typeface="Courier"/>
+              </a:rPr>
+              <a:t> modules</a:t>
+            </a:r>
+            <a:br/>
+            <a:r>
+              <a:rPr>
+                <a:latin typeface="Courier"/>
+              </a:rPr>
+              <a:t>               </a:t>
+            </a:r>
+            <a:r>
+              <a:rPr b="1">
+                <a:solidFill>
+                  <a:srgbClr val="007020"/>
+                </a:solidFill>
+                <a:latin typeface="Courier"/>
+              </a:rPr>
+              <a:t>for</a:t>
+            </a:r>
+            <a:r>
+              <a:rPr>
+                <a:latin typeface="Courier"/>
+              </a:rPr>
+              <a:t> p </a:t>
+            </a:r>
+            <a:r>
+              <a:rPr b="1">
+                <a:solidFill>
+                  <a:srgbClr val="007020"/>
+                </a:solidFill>
+                <a:latin typeface="Courier"/>
+              </a:rPr>
+              <a:t>in</a:t>
+            </a:r>
+            <a:r>
+              <a:rPr>
+                <a:latin typeface="Courier"/>
+              </a:rPr>
+              <a:t> m.parameters())</a:t>
+            </a:r>
+            <a:br/>
+            <a:br/>
+            <a:r>
+              <a:rPr>
+                <a:latin typeface="Courier"/>
+              </a:rPr>
+              <a:t>V </a:t>
+            </a:r>
+            <a:r>
+              <a:rPr>
+                <a:solidFill>
+                  <a:srgbClr val="666666"/>
+                </a:solidFill>
+                <a:latin typeface="Courier"/>
+              </a:rPr>
+              <a:t>=</a:t>
+            </a:r>
+            <a:r>
+              <a:rPr>
+                <a:latin typeface="Courier"/>
+              </a:rPr>
+              <a:t> </a:t>
+            </a:r>
+            <a:r>
+              <a:rPr>
+                <a:solidFill>
+                  <a:srgbClr val="40A070"/>
+                </a:solidFill>
+                <a:latin typeface="Courier"/>
+              </a:rPr>
+              <a:t>10_001</a:t>
+            </a:r>
+            <a:r>
+              <a:rPr>
+                <a:latin typeface="Courier"/>
+              </a:rPr>
+              <a:t>  </a:t>
+            </a:r>
+            <a:r>
+              <a:rPr i="1">
+                <a:solidFill>
+                  <a:srgbClr val="60A0B0"/>
+                </a:solidFill>
+                <a:latin typeface="Courier"/>
+              </a:rPr>
+              <a:t># vocabulary size</a:t>
+            </a:r>
+            <a:br/>
+            <a:r>
+              <a:rPr>
+                <a:latin typeface="Courier"/>
+              </a:rPr>
+              <a:t>one_hot </a:t>
+            </a:r>
+            <a:r>
+              <a:rPr>
+                <a:solidFill>
+                  <a:srgbClr val="666666"/>
+                </a:solidFill>
+                <a:latin typeface="Courier"/>
+              </a:rPr>
+              <a:t>=</a:t>
+            </a:r>
+            <a:r>
+              <a:rPr>
+                <a:latin typeface="Courier"/>
+              </a:rPr>
+              <a:t> [nn.GRU(V, </a:t>
+            </a:r>
+            <a:r>
+              <a:rPr>
+                <a:solidFill>
+                  <a:srgbClr val="40A070"/>
+                </a:solidFill>
+                <a:latin typeface="Courier"/>
+              </a:rPr>
+              <a:t>256</a:t>
+            </a:r>
+            <a:r>
+              <a:rPr>
+                <a:latin typeface="Courier"/>
+              </a:rPr>
+              <a:t>),</a:t>
+            </a:r>
+            <a:br/>
+            <a:r>
+              <a:rPr>
+                <a:latin typeface="Courier"/>
+              </a:rPr>
+              <a:t>           nn.Linear(</a:t>
+            </a:r>
+            <a:r>
+              <a:rPr>
+                <a:solidFill>
+                  <a:srgbClr val="40A070"/>
+                </a:solidFill>
+                <a:latin typeface="Courier"/>
+              </a:rPr>
+              <a:t>256</a:t>
+            </a:r>
+            <a:r>
+              <a:rPr>
+                <a:latin typeface="Courier"/>
+              </a:rPr>
+              <a:t>, V)]</a:t>
+            </a:r>
+            <a:br/>
+            <a:r>
+              <a:rPr>
+                <a:latin typeface="Courier"/>
+              </a:rPr>
+              <a:t>embedded </a:t>
+            </a:r>
+            <a:r>
+              <a:rPr>
+                <a:solidFill>
+                  <a:srgbClr val="666666"/>
+                </a:solidFill>
+                <a:latin typeface="Courier"/>
+              </a:rPr>
+              <a:t>=</a:t>
+            </a:r>
+            <a:r>
+              <a:rPr>
+                <a:latin typeface="Courier"/>
+              </a:rPr>
+              <a:t> [nn.Embedding(V, </a:t>
+            </a:r>
+            <a:r>
+              <a:rPr>
+                <a:solidFill>
+                  <a:srgbClr val="40A070"/>
+                </a:solidFill>
+                <a:latin typeface="Courier"/>
+              </a:rPr>
+              <a:t>100</a:t>
+            </a:r>
+            <a:r>
+              <a:rPr>
+                <a:latin typeface="Courier"/>
+              </a:rPr>
+              <a:t>),</a:t>
+            </a:r>
+            <a:br/>
+            <a:r>
+              <a:rPr>
+                <a:latin typeface="Courier"/>
+              </a:rPr>
+              <a:t>            nn.GRU(</a:t>
+            </a:r>
+            <a:r>
+              <a:rPr>
+                <a:solidFill>
+                  <a:srgbClr val="40A070"/>
+                </a:solidFill>
+                <a:latin typeface="Courier"/>
+              </a:rPr>
+              <a:t>100</a:t>
+            </a:r>
+            <a:r>
+              <a:rPr>
+                <a:latin typeface="Courier"/>
+              </a:rPr>
+              <a:t>, </a:t>
+            </a:r>
+            <a:r>
+              <a:rPr>
+                <a:solidFill>
+                  <a:srgbClr val="40A070"/>
+                </a:solidFill>
+                <a:latin typeface="Courier"/>
+              </a:rPr>
+              <a:t>256</a:t>
+            </a:r>
+            <a:r>
+              <a:rPr>
+                <a:latin typeface="Courier"/>
+              </a:rPr>
+              <a:t>),</a:t>
+            </a:r>
+            <a:br/>
+            <a:r>
+              <a:rPr>
+                <a:latin typeface="Courier"/>
+              </a:rPr>
+              <a:t>            nn.Linear(</a:t>
+            </a:r>
+            <a:r>
+              <a:rPr>
+                <a:solidFill>
+                  <a:srgbClr val="40A070"/>
+                </a:solidFill>
+                <a:latin typeface="Courier"/>
+              </a:rPr>
+              <a:t>256</a:t>
+            </a:r>
+            <a:r>
+              <a:rPr>
+                <a:latin typeface="Courier"/>
+              </a:rPr>
+              <a:t>, </a:t>
+            </a:r>
+            <a:r>
+              <a:rPr>
+                <a:solidFill>
+                  <a:srgbClr val="40A070"/>
+                </a:solidFill>
+                <a:latin typeface="Courier"/>
+              </a:rPr>
+              <a:t>100</a:t>
+            </a:r>
+            <a:r>
+              <a:rPr>
+                <a:latin typeface="Courier"/>
+              </a:rPr>
+              <a:t>),</a:t>
+            </a:r>
+            <a:br/>
+            <a:r>
+              <a:rPr>
+                <a:latin typeface="Courier"/>
+              </a:rPr>
+              <a:t>            nn.Linear(</a:t>
+            </a:r>
+            <a:r>
+              <a:rPr>
+                <a:solidFill>
+                  <a:srgbClr val="40A070"/>
+                </a:solidFill>
+                <a:latin typeface="Courier"/>
+              </a:rPr>
+              <a:t>100</a:t>
+            </a:r>
+            <a:r>
+              <a:rPr>
+                <a:latin typeface="Courier"/>
+              </a:rPr>
+              <a:t>, V)]</a:t>
+            </a:r>
+            <a:br/>
+            <a:r>
+              <a:rPr>
+                <a:latin typeface="Courier"/>
+              </a:rPr>
+              <a:t>n_params(</a:t>
+            </a:r>
+            <a:r>
+              <a:rPr>
+                <a:solidFill>
+                  <a:srgbClr val="666666"/>
+                </a:solidFill>
+                <a:latin typeface="Courier"/>
+              </a:rPr>
+              <a:t>*</a:t>
+            </a:r>
+            <a:r>
+              <a:rPr>
+                <a:latin typeface="Courier"/>
+              </a:rPr>
+              <a:t>one_hot), n_params(</a:t>
+            </a:r>
+            <a:r>
+              <a:rPr>
+                <a:solidFill>
+                  <a:srgbClr val="666666"/>
+                </a:solidFill>
+                <a:latin typeface="Courier"/>
+              </a:rPr>
+              <a:t>*</a:t>
+            </a:r>
+            <a:r>
+              <a:rPr>
+                <a:latin typeface="Courier"/>
+              </a:rPr>
+              <a:t>embedded)</a:t>
+            </a:r>
+          </a:p>
+        </p:txBody>
+      </p:sp>
+    </p:spTree>
+  </p:cSld>
+</p:sld>
+</file>
+
+<file path=ppt/slides/slide34.xml><?xml version="1.0" encoding="utf-8"?>
+<p:sld xmlns:a="http://schemas.openxmlformats.org/drawingml/2006/main" xmlns:r="http://schemas.openxmlformats.org/officeDocument/2006/relationships" xmlns:p="http://schemas.openxmlformats.org/presentationml/2006/main">
+  <p:cSld>
+    <p:spTree>
+      <p:nvGrpSpPr>
+        <p:cNvPr id="1" name=""/>
+        <p:cNvGrpSpPr/>
+        <p:nvPr/>
+      </p:nvGrpSpPr>
+      <p:grpSpPr>
+        <a:xfrm>
+          <a:off x="0" y="0"/>
+          <a:ext cx="0" cy="0"/>
+          <a:chOff x="0" y="0"/>
+          <a:chExt cx="0" cy="0"/>
+        </a:xfrm>
+      </p:grpSpPr>
+      <p:sp>
+        <p:nvSpPr>
+          <p:cNvPr id="2" name="Title 1"/>
+          <p:cNvSpPr>
+            <a:spLocks noGrp="1"/>
+          </p:cNvSpPr>
+          <p:nvPr>
+            <p:ph type="title"/>
+          </p:nvPr>
+        </p:nvSpPr>
+        <p:spPr/>
+        <p:txBody>
+          <a:bodyPr>
+            <a:normAutofit/>
+          </a:bodyPr>
+          <a:lstStyle/>
+          <a:p>
+            <a:pPr lvl="0" indent="0" marL="0">
+              <a:buNone/>
+            </a:pPr>
+            <a:r>
+              <a:rPr/>
+              <a:t>Embedding of one-hot selects a column</a:t>
+            </a:r>
+          </a:p>
+        </p:txBody>
+      </p:sp>
+      <p:pic>
+        <p:nvPicPr>
+          <p:cNvPr descr="img/onehot_select.png" id="0" name="Picture 1"/>
+          <p:cNvPicPr>
+            <a:picLocks noGrp="1" noChangeAspect="1"/>
+          </p:cNvPicPr>
+          <p:nvPr/>
+        </p:nvPicPr>
+        <p:blipFill>
+          <a:blip r:embed="rId3"/>
+          <a:stretch>
+            <a:fillRect/>
+          </a:stretch>
+        </p:blipFill>
+        <p:spPr bwMode="auto">
+          <a:xfrm>
+            <a:off x="457200" y="1193800"/>
+            <a:ext cx="8229600" cy="3390900"/>
+          </a:xfrm>
+          <a:prstGeom prst="rect">
+            <a:avLst/>
+          </a:prstGeom>
+          <a:noFill/>
+          <a:ln w="9525">
+            <a:noFill/>
+            <a:headEnd/>
+            <a:tailEnd/>
+          </a:ln>
+        </p:spPr>
+      </p:pic>
+    </p:spTree>
+  </p:cSld>
+</p:sld>
+</file>
+
+<file path=ppt/slides/slide35.xml><?xml version="1.0" encoding="utf-8"?>
+<p:sld xmlns:a="http://schemas.openxmlformats.org/drawingml/2006/main" xmlns:r="http://schemas.openxmlformats.org/officeDocument/2006/relationships" xmlns:p="http://schemas.openxmlformats.org/presentationml/2006/main">
+  <p:cSld>
+    <p:spTree>
+      <p:nvGrpSpPr>
+        <p:cNvPr id="1" name=""/>
+        <p:cNvGrpSpPr/>
+        <p:nvPr/>
+      </p:nvGrpSpPr>
+      <p:grpSpPr>
+        <a:xfrm>
+          <a:off x="0" y="0"/>
+          <a:ext cx="0" cy="0"/>
+          <a:chOff x="0" y="0"/>
+          <a:chExt cx="0" cy="0"/>
+        </a:xfrm>
+      </p:grpSpPr>
+      <p:sp>
+        <p:nvSpPr>
+          <p:cNvPr id="2" name="Title 1"/>
+          <p:cNvSpPr>
+            <a:spLocks noGrp="1"/>
+          </p:cNvSpPr>
+          <p:nvPr>
+            <p:ph type="title"/>
+          </p:nvPr>
+        </p:nvSpPr>
+        <p:spPr/>
+        <p:txBody>
+          <a:bodyPr>
+            <a:normAutofit/>
+          </a:bodyPr>
+          <a:lstStyle/>
+          <a:p>
+            <a:pPr lvl="0" indent="0" marL="0">
+              <a:buNone/>
+            </a:pPr>
+            <a:r>
+              <a:rPr/>
               <a:t>Reminder: Continuous Bag of Words</a:t>
             </a:r>
           </a:p>
@@ -9939,7 +10240,7 @@
 </p:sld>
 </file>
 
-<file path=ppt/slides/slide34.xml><?xml version="1.0" encoding="utf-8"?>
+<file path=ppt/slides/slide36.xml><?xml version="1.0" encoding="utf-8"?>
 <p:sld xmlns:a="http://schemas.openxmlformats.org/drawingml/2006/main" xmlns:r="http://schemas.openxmlformats.org/officeDocument/2006/relationships" xmlns:p="http://schemas.openxmlformats.org/presentationml/2006/main">
   <p:cSld>
     <p:spTree>
@@ -10018,7 +10319,7 @@
 </p:sld>
 </file>
 
-<file path=ppt/slides/slide35.xml><?xml version="1.0" encoding="utf-8"?>
+<file path=ppt/slides/slide37.xml><?xml version="1.0" encoding="utf-8"?>
 <p:sld xmlns:a="http://schemas.openxmlformats.org/drawingml/2006/main" xmlns:r="http://schemas.openxmlformats.org/officeDocument/2006/relationships" xmlns:p="http://schemas.openxmlformats.org/presentationml/2006/main">
   <p:cSld>
     <p:spTree>

</xml_diff>